<commit_message>
Trim speaker notes to bare cues across all 20 lecture decks
The notes layer was LLM-drafted prose (stage directions, closing lines,
slide-labeling meta-narration, claims about students as a population)
and two earlier voice passes made it worse by injecting voice markers at
5-10x the author's real rate. Replace every note with a 0-15 word cue:
quiz answers, numbers to say out loud, timings, demo instructions, and
the one point not already on the slide.

On-screen text is unchanged on every slide (verified by rendering each
deck before and after and diffing all non-notes lines). Slide counts are
unchanged. Note words: 53,329 -> 7,633; slides with a note: 845 -> 682.

Co-Authored-By: Claude Fable 5.1 <noreply@anthropic.com>
Claude-Session: https://claude.ai/code/session_01Pi7b72DvShCZNkTGKzrayU
</commit_message>
<xml_diff>
--- a/lectures/Lecture 1.1 - Software Engineering.pptx
+++ b/lectures/Lecture 1.1 - Software Engineering.pptx
@@ -835,22 +835,7 @@
             <a:noAutofit/>
           </a:bodyPr>
           <a:lstStyle/>
-          <a:p>
-            <a:pPr marL="0" lvl="0" indent="0" algn="l" rtl="0">
-              <a:spcBef>
-                <a:spcPts val="0"/>
-              </a:spcBef>
-              <a:spcAft>
-                <a:spcPts val="0"/>
-              </a:spcAft>
-              <a:buNone/>
-            </a:pPr>
-            <a:r>
-              <a:rPr lang="en-US"/>
-              <a:t>Welcome! It's project-based, and the whole idea is that we're layering an SE toolkit on top of the programming they already know how to do.</a:t>
-            </a:r>
-            <a:endParaRPr/>
-          </a:p>
+          <a:p/>
         </p:txBody>
       </p:sp>
       <p:sp>
@@ -994,20 +979,9 @@
           </a:bodyPr>
           <a:lstStyle/>
           <a:p>
-            <a:pPr marL="0" lvl="0" indent="0" algn="l" rtl="0">
-              <a:spcBef>
-                <a:spcPts val="0"/>
-              </a:spcBef>
-              <a:spcAft>
-                <a:spcPts val="0"/>
-              </a:spcAft>
-              <a:buNone/>
-            </a:pPr>
-            <a:r>
-              <a:rPr lang="en-US"/>
-              <a:t>What separates these is how much rope you hand it - a chatbot just answers you, an agent can go off and actually do things in a loop, and a coding agent is that same loop pointed at a codebase. They'll be living in the third one all semester.</a:t>
-            </a:r>
-            <a:endParaRPr/>
+            <a:r>
+              <a:t>They'll use coding agents all semester.</a:t>
+            </a:r>
           </a:p>
         </p:txBody>
       </p:sp>
@@ -1152,20 +1126,9 @@
           </a:bodyPr>
           <a:lstStyle/>
           <a:p>
-            <a:pPr marL="0" lvl="0" indent="0" algn="l" rtl="0">
-              <a:spcBef>
-                <a:spcPts val="0"/>
-              </a:spcBef>
-              <a:spcAft>
-                <a:spcPts val="0"/>
-              </a:spcAft>
-              <a:buNone/>
-            </a:pPr>
-            <a:r>
-              <a:rPr lang="en-US"/>
-              <a:t>Push on this one. The students who can tell you what their code actually does are gonna run circles around the ones who just take whatever came out of the agent, and since the exams are conceptual that shows up pretty fast.</a:t>
-            </a:r>
-            <a:endParaRPr/>
+            <a:r>
+              <a:t>Exams are conceptual; they need to explain what their code does.</a:t>
+            </a:r>
           </a:p>
         </p:txBody>
       </p:sp>
@@ -1310,20 +1273,9 @@
           </a:bodyPr>
           <a:lstStyle/>
           <a:p>
-            <a:pPr marL="0" lvl="0" indent="0" algn="l" rtl="0">
-              <a:spcBef>
-                <a:spcPts val="0"/>
-              </a:spcBef>
-              <a:spcAft>
-                <a:spcPts val="0"/>
-              </a:spcAft>
-              <a:buNone/>
-            </a:pPr>
-            <a:r>
-              <a:rPr lang="en-US"/>
-              <a:t>Push on this one. The students who can tell you what their code actually does are gonna run circles around the ones who just take whatever came out of the agent, and since the exams are conceptual that shows up pretty fast.</a:t>
-            </a:r>
-            <a:endParaRPr/>
+            <a:r>
+              <a:t>Exams are conceptual; they need to explain what their code does.</a:t>
+            </a:r>
           </a:p>
         </p:txBody>
       </p:sp>
@@ -1468,20 +1420,9 @@
           </a:bodyPr>
           <a:lstStyle/>
           <a:p>
-            <a:pPr marL="0" lvl="0" indent="0" algn="l" rtl="0">
-              <a:spcBef>
-                <a:spcPts val="0"/>
-              </a:spcBef>
-              <a:spcAft>
-                <a:spcPts val="0"/>
-              </a:spcAft>
-              <a:buNone/>
-            </a:pPr>
-            <a:r>
-              <a:rPr lang="en-US"/>
-              <a:t>Push on this one. The students who can tell you what their code actually does are gonna run circles around the ones who just take whatever came out of the agent, and since the exams are conceptual that shows up pretty fast.</a:t>
-            </a:r>
-            <a:endParaRPr/>
+            <a:r>
+              <a:t>Exams are conceptual; they need to explain what their code does.</a:t>
+            </a:r>
           </a:p>
         </p:txBody>
       </p:sp>
@@ -1626,20 +1567,9 @@
           </a:bodyPr>
           <a:lstStyle/>
           <a:p>
-            <a:pPr marL="0" lvl="0" indent="0" algn="l" rtl="0">
-              <a:spcBef>
-                <a:spcPts val="0"/>
-              </a:spcBef>
-              <a:spcAft>
-                <a:spcPts val="0"/>
-              </a:spcAft>
-              <a:buNone/>
-            </a:pPr>
-            <a:r>
-              <a:rPr lang="en-US"/>
-              <a:t>Push on this one. The students who can tell you what their code actually does are gonna run circles around the ones who just take whatever came out of the agent, and since the exams are conceptual that shows up pretty fast.</a:t>
-            </a:r>
-            <a:endParaRPr/>
+            <a:r>
+              <a:t>Exams are conceptual; they need to explain what their code does.</a:t>
+            </a:r>
           </a:p>
         </p:txBody>
       </p:sp>
@@ -1784,20 +1714,9 @@
           </a:bodyPr>
           <a:lstStyle/>
           <a:p>
-            <a:pPr marL="0" lvl="0" indent="0" algn="l" rtl="0">
-              <a:spcBef>
-                <a:spcPts val="0"/>
-              </a:spcBef>
-              <a:spcAft>
-                <a:spcPts val="0"/>
-              </a:spcAft>
-              <a:buNone/>
-            </a:pPr>
-            <a:r>
-              <a:rPr lang="en-US"/>
-              <a:t>Push on this one. The students who can tell you what their code actually does are gonna run circles around the ones who just take whatever came out of the agent, and since the exams are conceptual that shows up pretty fast.</a:t>
-            </a:r>
-            <a:endParaRPr/>
+            <a:r>
+              <a:t>Exams are conceptual; they need to explain what their code does.</a:t>
+            </a:r>
           </a:p>
         </p:txBody>
       </p:sp>
@@ -1942,20 +1861,9 @@
           </a:bodyPr>
           <a:lstStyle/>
           <a:p>
-            <a:pPr marL="0" lvl="0" indent="0" algn="l" rtl="0">
-              <a:spcBef>
-                <a:spcPts val="0"/>
-              </a:spcBef>
-              <a:spcAft>
-                <a:spcPts val="0"/>
-              </a:spcAft>
-              <a:buNone/>
-            </a:pPr>
-            <a:r>
-              <a:rPr lang="en-US"/>
-              <a:t>Push on this one. The students who can tell you what their code actually does are gonna run circles around the ones who just take whatever came out of the agent, and since the exams are conceptual that shows up pretty fast.</a:t>
-            </a:r>
-            <a:endParaRPr/>
+            <a:r>
+              <a:t>Exams are conceptual; they need to explain what their code does.</a:t>
+            </a:r>
           </a:p>
         </p:txBody>
       </p:sp>
@@ -2100,20 +2008,9 @@
           </a:bodyPr>
           <a:lstStyle/>
           <a:p>
-            <a:pPr marL="0" lvl="0" indent="0" algn="l" rtl="0">
-              <a:spcBef>
-                <a:spcPts val="0"/>
-              </a:spcBef>
-              <a:spcAft>
-                <a:spcPts val="0"/>
-              </a:spcAft>
-              <a:buNone/>
-            </a:pPr>
-            <a:r>
-              <a:rPr lang="en-US"/>
-              <a:t>Push on this one. The students who can tell you what their code actually does are gonna run circles around the ones who just take whatever came out of the agent, and since the exams are conceptual that shows up pretty fast.</a:t>
-            </a:r>
-            <a:endParaRPr/>
+            <a:r>
+              <a:t>Exams are conceptual; they need to explain what their code does.</a:t>
+            </a:r>
           </a:p>
         </p:txBody>
       </p:sp>
@@ -2258,20 +2155,9 @@
           </a:bodyPr>
           <a:lstStyle/>
           <a:p>
-            <a:pPr marL="0" lvl="0" indent="0" algn="l" rtl="0">
-              <a:spcBef>
-                <a:spcPts val="0"/>
-              </a:spcBef>
-              <a:spcAft>
-                <a:spcPts val="0"/>
-              </a:spcAft>
-              <a:buNone/>
-            </a:pPr>
-            <a:r>
-              <a:rPr lang="en-US"/>
-              <a:t>Push on this one. The students who can tell you what their code actually does are gonna run circles around the ones who just take whatever came out of the agent, and since the exams are conceptual that shows up pretty fast.</a:t>
-            </a:r>
-            <a:endParaRPr/>
+            <a:r>
+              <a:t>Exams are conceptual; they need to explain what their code does.</a:t>
+            </a:r>
           </a:p>
         </p:txBody>
       </p:sp>
@@ -2416,20 +2302,9 @@
           </a:bodyPr>
           <a:lstStyle/>
           <a:p>
-            <a:pPr marL="0" lvl="0" indent="0" algn="l" rtl="0">
-              <a:spcBef>
-                <a:spcPts val="0"/>
-              </a:spcBef>
-              <a:spcAft>
-                <a:spcPts val="0"/>
-              </a:spcAft>
-              <a:buNone/>
-            </a:pPr>
-            <a:r>
-              <a:rPr lang="en-US"/>
-              <a:t>Push on this one. The students who can tell you what their code actually does are gonna run circles around the ones who just take whatever came out of the agent, and since the exams are conceptual that shows up pretty fast.</a:t>
-            </a:r>
-            <a:endParaRPr/>
+            <a:r>
+              <a:t>Exams are conceptual; they need to explain what their code does.</a:t>
+            </a:r>
           </a:p>
         </p:txBody>
       </p:sp>
@@ -2574,20 +2449,9 @@
           </a:bodyPr>
           <a:lstStyle/>
           <a:p>
-            <a:pPr marL="0" lvl="0" indent="0" algn="l" rtl="0">
-              <a:spcBef>
-                <a:spcPts val="0"/>
-              </a:spcBef>
-              <a:spcAft>
-                <a:spcPts val="0"/>
-              </a:spcAft>
-              <a:buNone/>
-            </a:pPr>
-            <a:r>
-              <a:rPr lang="en-US"/>
-              <a:t>Set expectations early, because this thing moves fast and covers a LOT of ground. And I want them using LLMs the whole way through, out in the open, not sneaking around with them.</a:t>
-            </a:r>
-            <a:endParaRPr/>
+            <a:r>
+              <a:t>Fast pace. LLM use is expected and out in the open.</a:t>
+            </a:r>
           </a:p>
         </p:txBody>
       </p:sp>
@@ -2732,20 +2596,9 @@
           </a:bodyPr>
           <a:lstStyle/>
           <a:p>
-            <a:pPr marL="0" lvl="0" indent="0" algn="l" rtl="0">
-              <a:spcBef>
-                <a:spcPts val="0"/>
-              </a:spcBef>
-              <a:spcAft>
-                <a:spcPts val="0"/>
-              </a:spcAft>
-              <a:buNone/>
-            </a:pPr>
-            <a:r>
-              <a:rPr lang="en-US"/>
-              <a:t>Push on this one. The students who can tell you what their code actually does are gonna run circles around the ones who just take whatever came out of the agent, and since the exams are conceptual that shows up pretty fast.</a:t>
-            </a:r>
-            <a:endParaRPr/>
+            <a:r>
+              <a:t>Exams are conceptual; they need to explain what their code does.</a:t>
+            </a:r>
           </a:p>
         </p:txBody>
       </p:sp>
@@ -2890,20 +2743,9 @@
           </a:bodyPr>
           <a:lstStyle/>
           <a:p>
-            <a:pPr marL="0" lvl="0" indent="0" algn="l" rtl="0">
-              <a:spcBef>
-                <a:spcPts val="0"/>
-              </a:spcBef>
-              <a:spcAft>
-                <a:spcPts val="0"/>
-              </a:spcAft>
-              <a:buNone/>
-            </a:pPr>
-            <a:r>
-              <a:rPr lang="en-US"/>
-              <a:t>Push on this one. The students who can tell you what their code actually does are gonna run circles around the ones who just take whatever came out of the agent, and since the exams are conceptual that shows up pretty fast.</a:t>
-            </a:r>
-            <a:endParaRPr/>
+            <a:r>
+              <a:t>Exams are conceptual; they need to explain what their code does.</a:t>
+            </a:r>
           </a:p>
         </p:txBody>
       </p:sp>
@@ -3048,20 +2890,9 @@
           </a:bodyPr>
           <a:lstStyle/>
           <a:p>
-            <a:pPr marL="0" lvl="0" indent="0" algn="l" rtl="0">
-              <a:spcBef>
-                <a:spcPts val="0"/>
-              </a:spcBef>
-              <a:spcAft>
-                <a:spcPts val="0"/>
-              </a:spcAft>
-              <a:buNone/>
-            </a:pPr>
-            <a:r>
-              <a:rPr lang="en-US"/>
-              <a:t>Core mental model. Everything after this hangs off it.</a:t>
-            </a:r>
-            <a:endParaRPr/>
+            <a:r>
+              <a:t>Core mental model for the rest of the course.</a:t>
+            </a:r>
           </a:p>
         </p:txBody>
       </p:sp>
@@ -3206,20 +3037,9 @@
           </a:bodyPr>
           <a:lstStyle/>
           <a:p>
-            <a:pPr marL="0" lvl="0" indent="0" algn="l" rtl="0">
-              <a:spcBef>
-                <a:spcPts val="0"/>
-              </a:spcBef>
-              <a:spcAft>
-                <a:spcPts val="0"/>
-              </a:spcAft>
-              <a:buNone/>
-            </a:pPr>
-            <a:r>
-              <a:rPr lang="en-US"/>
-              <a:t>Walk each layer - browser up top, Python server in the middle, database at the bottom - and then spend a minute on the arrows, because the arrows are the part they haven't seen before.</a:t>
-            </a:r>
-            <a:endParaRPr/>
+            <a:r>
+              <a:t>Walk each layer top to bottom, then spend a minute on the arrows.</a:t>
+            </a:r>
           </a:p>
         </p:txBody>
       </p:sp>
@@ -5490,20 +5310,9 @@
           </a:bodyPr>
           <a:lstStyle/>
           <a:p>
-            <a:pPr marL="0" lvl="0" indent="0" algn="l" rtl="0">
-              <a:spcBef>
-                <a:spcPts val="0"/>
-              </a:spcBef>
-              <a:spcAft>
-                <a:spcPts val="0"/>
-              </a:spcAft>
-              <a:buNone/>
-            </a:pPr>
-            <a:r>
-              <a:rPr lang="en-US"/>
-              <a:t>Roadmap slide. Weeks 1-6 they build the chat app piece by piece on their own, then week 7 they pair up (or trio up) and it goes open-ended.</a:t>
-            </a:r>
-            <a:endParaRPr/>
+            <a:r>
+              <a:t>Weeks 1-6 build the chat app solo; week 7 pairs/trios, open-ended.</a:t>
+            </a:r>
           </a:p>
         </p:txBody>
       </p:sp>
@@ -5960,20 +5769,9 @@
           </a:bodyPr>
           <a:lstStyle/>
           <a:p>
-            <a:pPr marL="0" lvl="0" indent="0" algn="l" rtl="0">
-              <a:spcBef>
-                <a:spcPts val="0"/>
-              </a:spcBef>
-              <a:spcAft>
-                <a:spcPts val="0"/>
-              </a:spcAft>
-              <a:buNone/>
-            </a:pPr>
-            <a:r>
-              <a:rPr lang="en-US"/>
-              <a:t>What separates these is how much rope you hand it - a chatbot just answers you, an agent can go off and actually do things in a loop, and a coding agent is that same loop pointed at a codebase. They'll be living in the third one all semester.</a:t>
-            </a:r>
-            <a:endParaRPr/>
+            <a:r>
+              <a:t>They'll use coding agents all semester.</a:t>
+            </a:r>
           </a:p>
         </p:txBody>
       </p:sp>
@@ -6118,20 +5916,9 @@
           </a:bodyPr>
           <a:lstStyle/>
           <a:p>
-            <a:pPr marL="0" lvl="0" indent="0" algn="l" rtl="0">
-              <a:spcBef>
-                <a:spcPts val="0"/>
-              </a:spcBef>
-              <a:spcAft>
-                <a:spcPts val="0"/>
-              </a:spcAft>
-              <a:buNone/>
-            </a:pPr>
-            <a:r>
-              <a:rPr lang="en-US"/>
-              <a:t>What separates these is how much rope you hand it - a chatbot just answers you, an agent can go off and actually do things in a loop, and a coding agent is that same loop pointed at a codebase. They'll be living in the third one all semester.</a:t>
-            </a:r>
-            <a:endParaRPr/>
+            <a:r>
+              <a:t>They'll use coding agents all semester.</a:t>
+            </a:r>
           </a:p>
         </p:txBody>
       </p:sp>

</xml_diff>